<commit_message>
- added unit 4 - added front-end & backend project
</commit_message>
<xml_diff>
--- a/Project/UNIT_4/Unit- 4.pptx
+++ b/Project/UNIT_4/Unit- 4.pptx
@@ -22712,8 +22712,8 @@
         </p:nvSpPr>
         <p:spPr>
           <a:xfrm>
-            <a:off x="310896" y="1481328"/>
-            <a:ext cx="8522208" cy="3474720"/>
+            <a:off x="310897" y="1481328"/>
+            <a:ext cx="4942174" cy="3474720"/>
           </a:xfrm>
           <a:prstGeom prst="rect">
             <a:avLst/>
@@ -22997,6 +22997,34 @@
             </a:r>
             <a:endParaRPr lang="en-US" sz="1100" dirty="0"/>
           </a:p>
+        </p:txBody>
+      </p:sp>
+      <p:sp>
+        <p:nvSpPr>
+          <p:cNvPr id="9" name="Text 5">
+            <a:extLst>
+              <a:ext uri="{FF2B5EF4-FFF2-40B4-BE49-F238E27FC236}">
+                <a16:creationId xmlns:a16="http://schemas.microsoft.com/office/drawing/2014/main" id="{85DD2172-95A0-43AE-F3DB-073FF60160A1}"/>
+              </a:ext>
+            </a:extLst>
+          </p:cNvPr>
+          <p:cNvSpPr/>
+          <p:nvPr/>
+        </p:nvSpPr>
+        <p:spPr>
+          <a:xfrm>
+            <a:off x="5593606" y="1475442"/>
+            <a:ext cx="3239499" cy="3474720"/>
+          </a:xfrm>
+          <a:prstGeom prst="rect">
+            <a:avLst/>
+          </a:prstGeom>
+          <a:noFill/>
+          <a:ln/>
+        </p:spPr>
+        <p:txBody>
+          <a:bodyPr wrap="square" rtlCol="0" anchor="t"/>
+          <a:lstStyle/>
           <a:p>
             <a:pPr marL="0" indent="0">
               <a:buNone/>
@@ -23141,6 +23169,42 @@
           </a:p>
         </p:txBody>
       </p:sp>
+      <p:cxnSp>
+        <p:nvCxnSpPr>
+          <p:cNvPr id="11" name="Straight Connector 10">
+            <a:extLst>
+              <a:ext uri="{FF2B5EF4-FFF2-40B4-BE49-F238E27FC236}">
+                <a16:creationId xmlns:a16="http://schemas.microsoft.com/office/drawing/2014/main" id="{72FA0A72-BA4D-ABFC-42E7-EE673ED2D6B5}"/>
+              </a:ext>
+            </a:extLst>
+          </p:cNvPr>
+          <p:cNvCxnSpPr/>
+          <p:nvPr/>
+        </p:nvCxnSpPr>
+        <p:spPr>
+          <a:xfrm>
+            <a:off x="5297214" y="1620695"/>
+            <a:ext cx="0" cy="3033286"/>
+          </a:xfrm>
+          <a:prstGeom prst="line">
+            <a:avLst/>
+          </a:prstGeom>
+        </p:spPr>
+        <p:style>
+          <a:lnRef idx="1">
+            <a:schemeClr val="accent2"/>
+          </a:lnRef>
+          <a:fillRef idx="0">
+            <a:schemeClr val="accent2"/>
+          </a:fillRef>
+          <a:effectRef idx="0">
+            <a:schemeClr val="accent2"/>
+          </a:effectRef>
+          <a:fontRef idx="minor">
+            <a:schemeClr val="tx1"/>
+          </a:fontRef>
+        </p:style>
+      </p:cxnSp>
     </p:spTree>
   </p:cSld>
   <p:clrMapOvr>
@@ -23232,7 +23296,7 @@
                 <a:ea typeface="Trebuchet MS" pitchFamily="34" charset="-122"/>
                 <a:cs typeface="Trebuchet MS" pitchFamily="34" charset="-120"/>
               </a:rPr>
-              <a:t>Fetch API – Using async/await (Cleaner Syntax)</a:t>
+              <a:t>Fetch API – Using async/await</a:t>
             </a:r>
             <a:endParaRPr lang="en-US" sz="2600" dirty="0"/>
           </a:p>
@@ -23343,7 +23407,7 @@
         <p:spPr>
           <a:xfrm>
             <a:off x="310896" y="1298448"/>
-            <a:ext cx="8522208" cy="3611880"/>
+            <a:ext cx="4998930" cy="3611880"/>
           </a:xfrm>
           <a:prstGeom prst="rect">
             <a:avLst/>
@@ -23689,26 +23753,65 @@
             </a:r>
             <a:endParaRPr lang="en-US" sz="1100" dirty="0"/>
           </a:p>
-          <a:p>
-            <a:pPr marL="0" indent="0">
-              <a:buNone/>
-            </a:pPr>
-            <a:endParaRPr lang="en-US" sz="1100" dirty="0"/>
-          </a:p>
-          <a:p>
-            <a:pPr marL="0" indent="0">
-              <a:buNone/>
-            </a:pPr>
-            <a:r>
-              <a:rPr lang="en-US" sz="1100" dirty="0">
-                <a:solidFill>
-                  <a:srgbClr val="E2E8F0"/>
-                </a:solidFill>
-                <a:latin typeface="Consolas" pitchFamily="34" charset="0"/>
-                <a:ea typeface="Consolas" pitchFamily="34" charset="-122"/>
-                <a:cs typeface="Consolas" pitchFamily="34" charset="-120"/>
-              </a:rPr>
-              <a:t>  if (error) return &lt;p style={{ color: 'red' }}&gt;{error}&lt;/p&gt;;</a:t>
+        </p:txBody>
+      </p:sp>
+      <p:sp>
+        <p:nvSpPr>
+          <p:cNvPr id="8" name="Text 5">
+            <a:extLst>
+              <a:ext uri="{FF2B5EF4-FFF2-40B4-BE49-F238E27FC236}">
+                <a16:creationId xmlns:a16="http://schemas.microsoft.com/office/drawing/2014/main" id="{1206F79C-61DE-B6A3-A83D-18BEAEC0BC98}"/>
+              </a:ext>
+            </a:extLst>
+          </p:cNvPr>
+          <p:cNvSpPr/>
+          <p:nvPr/>
+        </p:nvSpPr>
+        <p:spPr>
+          <a:xfrm>
+            <a:off x="5499013" y="1389888"/>
+            <a:ext cx="4408668" cy="3611880"/>
+          </a:xfrm>
+          <a:prstGeom prst="rect">
+            <a:avLst/>
+          </a:prstGeom>
+          <a:noFill/>
+          <a:ln/>
+        </p:spPr>
+        <p:txBody>
+          <a:bodyPr wrap="square" rtlCol="0" anchor="t"/>
+          <a:lstStyle/>
+          <a:p>
+            <a:pPr marL="0" indent="0">
+              <a:buNone/>
+            </a:pPr>
+            <a:r>
+              <a:rPr lang="en-US" sz="1100" dirty="0">
+                <a:solidFill>
+                  <a:srgbClr val="E2E8F0"/>
+                </a:solidFill>
+                <a:latin typeface="Consolas" pitchFamily="34" charset="0"/>
+                <a:ea typeface="Consolas" pitchFamily="34" charset="-122"/>
+                <a:cs typeface="Consolas" pitchFamily="34" charset="-120"/>
+              </a:rPr>
+              <a:t>          </a:t>
+            </a:r>
+            <a:endParaRPr lang="en-US" sz="1100" dirty="0"/>
+          </a:p>
+          <a:p>
+            <a:pPr marL="0" indent="0">
+              <a:buNone/>
+            </a:pPr>
+            <a:r>
+              <a:rPr lang="en-US" sz="1100" dirty="0">
+                <a:solidFill>
+                  <a:srgbClr val="E2E8F0"/>
+                </a:solidFill>
+                <a:latin typeface="Consolas" pitchFamily="34" charset="0"/>
+                <a:ea typeface="Consolas" pitchFamily="34" charset="-122"/>
+                <a:cs typeface="Consolas" pitchFamily="34" charset="-120"/>
+              </a:rPr>
+              <a:t>if (error) return &lt;p style={{ color: 'red' }}&gt;{error}&lt;/p&gt;;</a:t>
             </a:r>
             <a:endParaRPr lang="en-US" sz="1100" dirty="0"/>
           </a:p>
@@ -23748,6 +23851,42 @@
           </a:p>
         </p:txBody>
       </p:sp>
+      <p:cxnSp>
+        <p:nvCxnSpPr>
+          <p:cNvPr id="10" name="Straight Connector 9">
+            <a:extLst>
+              <a:ext uri="{FF2B5EF4-FFF2-40B4-BE49-F238E27FC236}">
+                <a16:creationId xmlns:a16="http://schemas.microsoft.com/office/drawing/2014/main" id="{75759ED3-5088-32EB-627A-98EC391EA8D8}"/>
+              </a:ext>
+            </a:extLst>
+          </p:cNvPr>
+          <p:cNvCxnSpPr/>
+          <p:nvPr/>
+        </p:nvCxnSpPr>
+        <p:spPr>
+          <a:xfrm>
+            <a:off x="5259421" y="1389888"/>
+            <a:ext cx="50405" cy="3383150"/>
+          </a:xfrm>
+          <a:prstGeom prst="line">
+            <a:avLst/>
+          </a:prstGeom>
+        </p:spPr>
+        <p:style>
+          <a:lnRef idx="1">
+            <a:schemeClr val="accent2"/>
+          </a:lnRef>
+          <a:fillRef idx="0">
+            <a:schemeClr val="accent2"/>
+          </a:fillRef>
+          <a:effectRef idx="0">
+            <a:schemeClr val="accent2"/>
+          </a:effectRef>
+          <a:fontRef idx="minor">
+            <a:schemeClr val="tx1"/>
+          </a:fontRef>
+        </p:style>
+      </p:cxnSp>
     </p:spTree>
   </p:cSld>
   <p:clrMapOvr>
@@ -24160,7 +24299,7 @@
         <p:spPr>
           <a:xfrm>
             <a:off x="201168" y="1664208"/>
-            <a:ext cx="4251960" cy="2286000"/>
+            <a:ext cx="3942010" cy="2286000"/>
           </a:xfrm>
           <a:prstGeom prst="rect">
             <a:avLst/>
@@ -24233,7 +24372,7 @@
                 <a:ea typeface="Consolas" pitchFamily="34" charset="-122"/>
                 <a:cs typeface="Consolas" pitchFamily="34" charset="-120"/>
               </a:rPr>
-              <a:t>localStorage.setItem('username', 'Priya');</a:t>
+              <a:t>localStorage.setItem('username', ‘Jeet');</a:t>
             </a:r>
             <a:endParaRPr lang="en-US" sz="1100" dirty="0"/>
           </a:p>
@@ -24290,7 +24429,7 @@
                 <a:ea typeface="Consolas" pitchFamily="34" charset="-122"/>
                 <a:cs typeface="Consolas" pitchFamily="34" charset="-120"/>
               </a:rPr>
-              <a:t>// name = 'Priya'</a:t>
+              <a:t>// name = ‘Jeet'</a:t>
             </a:r>
             <a:endParaRPr lang="en-US" sz="1100" dirty="0"/>
           </a:p>
@@ -24409,7 +24548,18 @@
                 <a:ea typeface="Trebuchet MS" pitchFamily="34" charset="-122"/>
                 <a:cs typeface="Trebuchet MS" pitchFamily="34" charset="-120"/>
               </a:rPr>
-              <a:t>React + Local Storage (practical example):</a:t>
+              <a:t>React + </a:t>
+            </a:r>
+            <a:r>
+              <a:rPr lang="en-US" sz="1300" b="1">
+                <a:solidFill>
+                  <a:srgbClr val="0284C7"/>
+                </a:solidFill>
+                <a:latin typeface="Trebuchet MS" pitchFamily="34" charset="0"/>
+                <a:ea typeface="Trebuchet MS" pitchFamily="34" charset="-122"/>
+                <a:cs typeface="Trebuchet MS" pitchFamily="34" charset="-120"/>
+              </a:rPr>
+              <a:t>Local Storage:</a:t>
             </a:r>
             <a:endParaRPr lang="en-US" sz="1300" dirty="0"/>
           </a:p>
@@ -24423,8 +24573,8 @@
         </p:nvSpPr>
         <p:spPr>
           <a:xfrm>
-            <a:off x="4681728" y="1664208"/>
-            <a:ext cx="4251960" cy="2286000"/>
+            <a:off x="4252906" y="1664208"/>
+            <a:ext cx="4680782" cy="2564892"/>
           </a:xfrm>
           <a:prstGeom prst="rect">
             <a:avLst/>
@@ -24455,8 +24605,8 @@
         </p:nvSpPr>
         <p:spPr>
           <a:xfrm>
-            <a:off x="4791456" y="1755648"/>
-            <a:ext cx="4032504" cy="2103120"/>
+            <a:off x="4453128" y="1755648"/>
+            <a:ext cx="4590288" cy="2564892"/>
           </a:xfrm>
           <a:prstGeom prst="rect">
             <a:avLst/>
@@ -24539,12 +24689,6 @@
             <a:pPr marL="0" indent="0">
               <a:buNone/>
             </a:pPr>
-            <a:endParaRPr lang="en-US" sz="1100" dirty="0"/>
-          </a:p>
-          <a:p>
-            <a:pPr marL="0" indent="0">
-              <a:buNone/>
-            </a:pPr>
             <a:r>
               <a:rPr lang="en-US" sz="1100" dirty="0">
                 <a:solidFill>
@@ -24721,7 +24865,7 @@
         </p:nvSpPr>
         <p:spPr>
           <a:xfrm>
-            <a:off x="201168" y="4041648"/>
+            <a:off x="201168" y="4344339"/>
             <a:ext cx="8741664" cy="713232"/>
           </a:xfrm>
           <a:prstGeom prst="rect">
@@ -24753,7 +24897,7 @@
         </p:nvSpPr>
         <p:spPr>
           <a:xfrm>
-            <a:off x="338328" y="4151376"/>
+            <a:off x="338328" y="4454067"/>
             <a:ext cx="8467344" cy="493776"/>
           </a:xfrm>
           <a:prstGeom prst="rect">
@@ -25310,8 +25454,8 @@
         </p:nvSpPr>
         <p:spPr>
           <a:xfrm>
-            <a:off x="1371600" y="2724912"/>
-            <a:ext cx="2560320" cy="502920"/>
+            <a:off x="1371600" y="2447448"/>
+            <a:ext cx="2560320" cy="474061"/>
           </a:xfrm>
           <a:prstGeom prst="rect">
             <a:avLst/>
@@ -25342,7 +25486,7 @@
         </p:nvSpPr>
         <p:spPr>
           <a:xfrm>
-            <a:off x="1371600" y="2724912"/>
+            <a:off x="1371600" y="2447448"/>
             <a:ext cx="2560320" cy="502920"/>
           </a:xfrm>
           <a:prstGeom prst="rect">
@@ -25398,8 +25542,8 @@
         </p:nvSpPr>
         <p:spPr>
           <a:xfrm>
-            <a:off x="5212080" y="2724912"/>
-            <a:ext cx="2560320" cy="502920"/>
+            <a:off x="5212080" y="2447448"/>
+            <a:ext cx="2560320" cy="474061"/>
           </a:xfrm>
           <a:prstGeom prst="rect">
             <a:avLst/>
@@ -25430,7 +25574,7 @@
         </p:nvSpPr>
         <p:spPr>
           <a:xfrm>
-            <a:off x="5212080" y="2724912"/>
+            <a:off x="5212080" y="2447448"/>
             <a:ext cx="2560320" cy="502920"/>
           </a:xfrm>
           <a:prstGeom prst="rect">
@@ -25486,7 +25630,7 @@
         </p:nvSpPr>
         <p:spPr>
           <a:xfrm>
-            <a:off x="1371600" y="3291840"/>
+            <a:off x="1371600" y="2965205"/>
             <a:ext cx="2560320" cy="274320"/>
           </a:xfrm>
           <a:prstGeom prst="rect">
@@ -25525,7 +25669,7 @@
         </p:nvSpPr>
         <p:spPr>
           <a:xfrm>
-            <a:off x="5212080" y="3291840"/>
+            <a:off x="5239512" y="2958890"/>
             <a:ext cx="2560320" cy="274320"/>
           </a:xfrm>
           <a:prstGeom prst="rect">
@@ -25564,8 +25708,8 @@
         </p:nvSpPr>
         <p:spPr>
           <a:xfrm>
-            <a:off x="201168" y="3657600"/>
-            <a:ext cx="8741664" cy="1435608"/>
+            <a:off x="201168" y="3317065"/>
+            <a:ext cx="8741664" cy="1776143"/>
           </a:xfrm>
           <a:prstGeom prst="rect">
             <a:avLst/>
@@ -25596,8 +25740,8 @@
         </p:nvSpPr>
         <p:spPr>
           <a:xfrm>
-            <a:off x="310896" y="3749040"/>
-            <a:ext cx="8522208" cy="1252728"/>
+            <a:off x="310896" y="3346564"/>
+            <a:ext cx="4210654" cy="1457040"/>
           </a:xfrm>
           <a:prstGeom prst="rect">
             <a:avLst/>
@@ -25778,6 +25922,34 @@
             </a:r>
             <a:endParaRPr lang="en-US" sz="1100" dirty="0"/>
           </a:p>
+        </p:txBody>
+      </p:sp>
+      <p:sp>
+        <p:nvSpPr>
+          <p:cNvPr id="18" name="Text 15">
+            <a:extLst>
+              <a:ext uri="{FF2B5EF4-FFF2-40B4-BE49-F238E27FC236}">
+                <a16:creationId xmlns:a16="http://schemas.microsoft.com/office/drawing/2014/main" id="{5277C6A8-4875-643C-FA45-79D133F06DA6}"/>
+              </a:ext>
+            </a:extLst>
+          </p:cNvPr>
+          <p:cNvSpPr/>
+          <p:nvPr/>
+        </p:nvSpPr>
+        <p:spPr>
+          <a:xfrm>
+            <a:off x="4707369" y="3461617"/>
+            <a:ext cx="4210654" cy="1905455"/>
+          </a:xfrm>
+          <a:prstGeom prst="rect">
+            <a:avLst/>
+          </a:prstGeom>
+          <a:noFill/>
+          <a:ln/>
+        </p:spPr>
+        <p:txBody>
+          <a:bodyPr wrap="square" rtlCol="0" anchor="t"/>
+          <a:lstStyle/>
           <a:p>
             <a:pPr marL="0" indent="0">
               <a:buNone/>
@@ -25882,6 +26054,42 @@
           </a:p>
         </p:txBody>
       </p:sp>
+      <p:cxnSp>
+        <p:nvCxnSpPr>
+          <p:cNvPr id="20" name="Straight Connector 19">
+            <a:extLst>
+              <a:ext uri="{FF2B5EF4-FFF2-40B4-BE49-F238E27FC236}">
+                <a16:creationId xmlns:a16="http://schemas.microsoft.com/office/drawing/2014/main" id="{A8740776-7CA5-5AE9-4205-49939A915942}"/>
+              </a:ext>
+            </a:extLst>
+          </p:cNvPr>
+          <p:cNvCxnSpPr/>
+          <p:nvPr/>
+        </p:nvCxnSpPr>
+        <p:spPr>
+          <a:xfrm>
+            <a:off x="4395426" y="3461617"/>
+            <a:ext cx="0" cy="1394162"/>
+          </a:xfrm>
+          <a:prstGeom prst="line">
+            <a:avLst/>
+          </a:prstGeom>
+        </p:spPr>
+        <p:style>
+          <a:lnRef idx="1">
+            <a:schemeClr val="accent2"/>
+          </a:lnRef>
+          <a:fillRef idx="0">
+            <a:schemeClr val="accent2"/>
+          </a:fillRef>
+          <a:effectRef idx="0">
+            <a:schemeClr val="accent2"/>
+          </a:effectRef>
+          <a:fontRef idx="minor">
+            <a:schemeClr val="tx1"/>
+          </a:fontRef>
+        </p:style>
+      </p:cxnSp>
     </p:spTree>
   </p:cSld>
   <p:clrMapOvr>
@@ -26545,8 +26753,8 @@
         </p:nvSpPr>
         <p:spPr>
           <a:xfrm>
-            <a:off x="310896" y="2103120"/>
-            <a:ext cx="4032504" cy="2743200"/>
+            <a:off x="274320" y="2103120"/>
+            <a:ext cx="4142232" cy="2743200"/>
           </a:xfrm>
           <a:prstGeom prst="rect">
             <a:avLst/>
@@ -26604,24 +26812,7 @@
                 <a:ea typeface="Consolas" pitchFamily="34" charset="-122"/>
                 <a:cs typeface="Consolas" pitchFamily="34" charset="-120"/>
               </a:rPr>
-              <a:t>  return (</a:t>
-            </a:r>
-            <a:endParaRPr lang="en-US" sz="1100" dirty="0"/>
-          </a:p>
-          <a:p>
-            <a:pPr marL="0" indent="0">
-              <a:buNone/>
-            </a:pPr>
-            <a:r>
-              <a:rPr lang="en-US" sz="1100" dirty="0">
-                <a:solidFill>
-                  <a:srgbClr val="E2E8F0"/>
-                </a:solidFill>
-                <a:latin typeface="Consolas" pitchFamily="34" charset="0"/>
-                <a:ea typeface="Consolas" pitchFamily="34" charset="-122"/>
-                <a:cs typeface="Consolas" pitchFamily="34" charset="-120"/>
-              </a:rPr>
-              <a:t>    &lt;div className='card'&gt;</a:t>
+              <a:t>  return (    &lt;div className='card'&gt;</a:t>
             </a:r>
             <a:endParaRPr lang="en-US" sz="1100" dirty="0"/>
           </a:p>
@@ -26689,58 +26880,7 @@
                 <a:ea typeface="Consolas" pitchFamily="34" charset="-122"/>
                 <a:cs typeface="Consolas" pitchFamily="34" charset="-120"/>
               </a:rPr>
-              <a:t>      &lt;/div&gt;</a:t>
-            </a:r>
-            <a:endParaRPr lang="en-US" sz="1100" dirty="0"/>
-          </a:p>
-          <a:p>
-            <a:pPr marL="0" indent="0">
-              <a:buNone/>
-            </a:pPr>
-            <a:r>
-              <a:rPr lang="en-US" sz="1100" dirty="0">
-                <a:solidFill>
-                  <a:srgbClr val="E2E8F0"/>
-                </a:solidFill>
-                <a:latin typeface="Consolas" pitchFamily="34" charset="0"/>
-                <a:ea typeface="Consolas" pitchFamily="34" charset="-122"/>
-                <a:cs typeface="Consolas" pitchFamily="34" charset="-120"/>
-              </a:rPr>
-              <a:t>    &lt;/div&gt;</a:t>
-            </a:r>
-            <a:endParaRPr lang="en-US" sz="1100" dirty="0"/>
-          </a:p>
-          <a:p>
-            <a:pPr marL="0" indent="0">
-              <a:buNone/>
-            </a:pPr>
-            <a:r>
-              <a:rPr lang="en-US" sz="1100" dirty="0">
-                <a:solidFill>
-                  <a:srgbClr val="E2E8F0"/>
-                </a:solidFill>
-                <a:latin typeface="Consolas" pitchFamily="34" charset="0"/>
-                <a:ea typeface="Consolas" pitchFamily="34" charset="-122"/>
-                <a:cs typeface="Consolas" pitchFamily="34" charset="-120"/>
-              </a:rPr>
-              <a:t>  );</a:t>
-            </a:r>
-            <a:endParaRPr lang="en-US" sz="1100" dirty="0"/>
-          </a:p>
-          <a:p>
-            <a:pPr marL="0" indent="0">
-              <a:buNone/>
-            </a:pPr>
-            <a:r>
-              <a:rPr lang="en-US" sz="1100" dirty="0">
-                <a:solidFill>
-                  <a:srgbClr val="E2E8F0"/>
-                </a:solidFill>
-                <a:latin typeface="Consolas" pitchFamily="34" charset="0"/>
-                <a:ea typeface="Consolas" pitchFamily="34" charset="-122"/>
-                <a:cs typeface="Consolas" pitchFamily="34" charset="-120"/>
-              </a:rPr>
-              <a:t>}</a:t>
+              <a:t>      &lt;/div&gt;  &lt;/div&gt;  ); }</a:t>
             </a:r>
             <a:endParaRPr lang="en-US" sz="1100" dirty="0"/>
           </a:p>
@@ -26797,58 +26937,24 @@
                 <a:ea typeface="Consolas" pitchFamily="34" charset="-122"/>
                 <a:cs typeface="Consolas" pitchFamily="34" charset="-120"/>
               </a:rPr>
-              <a:t>  return (</a:t>
-            </a:r>
-            <a:endParaRPr lang="en-US" sz="1100" dirty="0"/>
-          </a:p>
-          <a:p>
-            <a:pPr marL="0" indent="0">
-              <a:buNone/>
-            </a:pPr>
-            <a:r>
-              <a:rPr lang="en-US" sz="1100" dirty="0">
-                <a:solidFill>
-                  <a:srgbClr val="E2E8F0"/>
-                </a:solidFill>
-                <a:latin typeface="Consolas" pitchFamily="34" charset="0"/>
-                <a:ea typeface="Consolas" pitchFamily="34" charset="-122"/>
-                <a:cs typeface="Consolas" pitchFamily="34" charset="-120"/>
-              </a:rPr>
-              <a:t>    &lt;Card title='Student Info'&gt;</a:t>
-            </a:r>
-            <a:endParaRPr lang="en-US" sz="1100" dirty="0"/>
-          </a:p>
-          <a:p>
-            <a:pPr marL="0" indent="0">
-              <a:buNone/>
-            </a:pPr>
-            <a:r>
-              <a:rPr lang="en-US" sz="1100" dirty="0">
-                <a:solidFill>
-                  <a:srgbClr val="E2E8F0"/>
-                </a:solidFill>
-                <a:latin typeface="Consolas" pitchFamily="34" charset="0"/>
-                <a:ea typeface="Consolas" pitchFamily="34" charset="-122"/>
-                <a:cs typeface="Consolas" pitchFamily="34" charset="-120"/>
-              </a:rPr>
-              <a:t>      &lt;p&gt;Name: Amit&lt;/p&gt;</a:t>
-            </a:r>
-            <a:endParaRPr lang="en-US" sz="1100" dirty="0"/>
-          </a:p>
-          <a:p>
-            <a:pPr marL="0" indent="0">
-              <a:buNone/>
-            </a:pPr>
-            <a:r>
-              <a:rPr lang="en-US" sz="1100" dirty="0">
-                <a:solidFill>
-                  <a:srgbClr val="E2E8F0"/>
-                </a:solidFill>
-                <a:latin typeface="Consolas" pitchFamily="34" charset="0"/>
-                <a:ea typeface="Consolas" pitchFamily="34" charset="-122"/>
-                <a:cs typeface="Consolas" pitchFamily="34" charset="-120"/>
-              </a:rPr>
-              <a:t>      &lt;p&gt;Course: MCA&lt;/p&gt;</a:t>
+              <a:t>  return (    &lt;Card title='Student Info'&gt;</a:t>
+            </a:r>
+            <a:endParaRPr lang="en-US" sz="1100" dirty="0"/>
+          </a:p>
+          <a:p>
+            <a:pPr marL="0" indent="0">
+              <a:buNone/>
+            </a:pPr>
+            <a:r>
+              <a:rPr lang="en-US" sz="1100" dirty="0">
+                <a:solidFill>
+                  <a:srgbClr val="E2E8F0"/>
+                </a:solidFill>
+                <a:latin typeface="Consolas" pitchFamily="34" charset="0"/>
+                <a:ea typeface="Consolas" pitchFamily="34" charset="-122"/>
+                <a:cs typeface="Consolas" pitchFamily="34" charset="-120"/>
+              </a:rPr>
+              <a:t>      &lt;p&gt;Name: Amit&lt;/p&gt;    &lt;p&gt;Course: MCA&lt;/p&gt;</a:t>
             </a:r>
             <a:endParaRPr lang="en-US" sz="1100" dirty="0"/>
           </a:p>
@@ -26882,24 +26988,7 @@
                 <a:ea typeface="Consolas" pitchFamily="34" charset="-122"/>
                 <a:cs typeface="Consolas" pitchFamily="34" charset="-120"/>
               </a:rPr>
-              <a:t>    &lt;/Card&gt;</a:t>
-            </a:r>
-            <a:endParaRPr lang="en-US" sz="1100" dirty="0"/>
-          </a:p>
-          <a:p>
-            <a:pPr marL="0" indent="0">
-              <a:buNone/>
-            </a:pPr>
-            <a:r>
-              <a:rPr lang="en-US" sz="1100" dirty="0">
-                <a:solidFill>
-                  <a:srgbClr val="E2E8F0"/>
-                </a:solidFill>
-                <a:latin typeface="Consolas" pitchFamily="34" charset="0"/>
-                <a:ea typeface="Consolas" pitchFamily="34" charset="-122"/>
-                <a:cs typeface="Consolas" pitchFamily="34" charset="-120"/>
-              </a:rPr>
-              <a:t>  );</a:t>
+              <a:t>    &lt;/Card&gt;  );</a:t>
             </a:r>
             <a:endParaRPr lang="en-US" sz="1100" dirty="0"/>
           </a:p>

</xml_diff>